<commit_message>
fix: check API connection before leaving guest mode from profile
- "Iniciar sesión" button now checks API connectivity first
- If online: logout and navigate to login screen
- If offline: logout and show connection modal (Recargar/Modo offline)
- Shows loading spinner while checking connection
- Updated architecture diagrams to reflect the new flow

Co-Authored-By: Claude Opus 4.6 <noreply@anthropic.com>
</commit_message>
<xml_diff>
--- a/docs/diagramas.pptx
+++ b/docs/diagramas.pptx
@@ -2470,7 +2470,7 @@
                 <a:ea typeface="Calibri" pitchFamily="34" charset="-122"/>
                 <a:cs typeface="Calibri" pitchFamily="34" charset="-120"/>
               </a:rPr>
-              <a:t>  Modal offline</a:t>
+              <a:t>  Modal offline (Recargar/Offline)</a:t>
             </a:r>
             <a:endParaRPr lang="en-US" sz="800" dirty="0"/>
           </a:p>
@@ -2788,7 +2788,7 @@
                 <a:ea typeface="Calibri" pitchFamily="34" charset="-122"/>
                 <a:cs typeface="Calibri" pitchFamily="34" charset="-120"/>
               </a:rPr>
-              <a:t>  Perfil + TAP + editar</a:t>
+              <a:t>  Perfil + TAP + check API</a:t>
             </a:r>
             <a:endParaRPr lang="en-US" sz="800" dirty="0"/>
           </a:p>
@@ -2927,7 +2927,7 @@
                 <a:ea typeface="Calibri" pitchFamily="34" charset="-122"/>
                 <a:cs typeface="Calibri" pitchFamily="34" charset="-120"/>
               </a:rPr>
-              <a:t>  Token, usuario, guest, login/logout</a:t>
+              <a:t>  Token, usuario, guest, cache completo</a:t>
             </a:r>
             <a:endParaRPr lang="en-US" sz="800" dirty="0"/>
           </a:p>
@@ -3832,8 +3832,8 @@
         </p:nvSpPr>
         <p:spPr>
           <a:xfrm>
-            <a:off x="365760" y="4389120"/>
-            <a:ext cx="8412480" cy="640080"/>
+            <a:off x="365760" y="4160520"/>
+            <a:ext cx="8412480" cy="868680"/>
           </a:xfrm>
           <a:prstGeom prst="rect">
             <a:avLst/>
@@ -3859,7 +3859,7 @@
         </p:nvSpPr>
         <p:spPr>
           <a:xfrm>
-            <a:off x="548640" y="4434840"/>
+            <a:off x="548640" y="4206240"/>
             <a:ext cx="8046720" cy="228600"/>
           </a:xfrm>
           <a:prstGeom prst="rect">
@@ -3898,8 +3898,8 @@
         </p:nvSpPr>
         <p:spPr>
           <a:xfrm>
-            <a:off x="548640" y="4681728"/>
-            <a:ext cx="8046720" cy="274320"/>
+            <a:off x="548640" y="4434840"/>
+            <a:ext cx="8046720" cy="228600"/>
           </a:xfrm>
           <a:prstGeom prst="rect">
             <a:avLst/>
@@ -3923,9 +3923,48 @@
                 <a:ea typeface="Calibri" pitchFamily="34" charset="-122"/>
                 <a:cs typeface="Calibri" pitchFamily="34" charset="-120"/>
               </a:rPr>
-              <a:t>App Start  →  Check API  →  Modal (online/offline)  →  Login / Guest  →  Tabs (Productos | Historial | Perfil)</a:t>
+              <a:t>App Start  →  Check API  →  Modal (Recargar / Modo offline)  →  Login / Guest  →  Tabs</a:t>
             </a:r>
             <a:endParaRPr lang="en-US" sz="1100" dirty="0"/>
+          </a:p>
+        </p:txBody>
+      </p:sp>
+      <p:sp>
+        <p:nvSpPr>
+          <p:cNvPr id="44" name="Text 42"/>
+          <p:cNvSpPr/>
+          <p:nvPr/>
+        </p:nvSpPr>
+        <p:spPr>
+          <a:xfrm>
+            <a:off x="548640" y="4690872"/>
+            <a:ext cx="8046720" cy="228600"/>
+          </a:xfrm>
+          <a:prstGeom prst="rect">
+            <a:avLst/>
+          </a:prstGeom>
+          <a:noFill/>
+          <a:ln/>
+        </p:spPr>
+        <p:txBody>
+          <a:bodyPr wrap="square" lIns="0" tIns="0" rIns="0" bIns="0" rtlCol="0" anchor="ctr"/>
+          <a:lstStyle/>
+          <a:p>
+            <a:pPr indent="0" marL="0">
+              <a:buNone/>
+            </a:pPr>
+            <a:r>
+              <a:rPr lang="en-US" sz="1000" i="1" dirty="0">
+                <a:solidFill>
+                  <a:srgbClr val="4B5563"/>
+                </a:solidFill>
+                <a:latin typeface="Calibri" pitchFamily="34" charset="0"/>
+                <a:ea typeface="Calibri" pitchFamily="34" charset="-122"/>
+                <a:cs typeface="Calibri" pitchFamily="34" charset="-120"/>
+              </a:rPr>
+              <a:t>Perfil (Guest)  →  "Iniciar sesion"  →  Check API  →  Online: Login | Offline: Modal reconexion</a:t>
+            </a:r>
+            <a:endParaRPr lang="en-US" sz="1000" dirty="0"/>
           </a:p>
         </p:txBody>
       </p:sp>

</xml_diff>